<commit_message>
Add updated presentation file
</commit_message>
<xml_diff>
--- a/reports/PickSense_Presentation.pptx
+++ b/reports/PickSense_Presentation.pptx
@@ -717,7 +717,7 @@
           <a:lstStyle/>
           <a:p>
             <a:r>
-              <a:t>Third, the model itself. This is a Vision Transformer, ViT-Base, and I deliberately built it from scratch rather than importing one, to really understand it. Here's the flow. First, patch embedding: a single Conv2d layer slices the two-twenty-four image into ninety-six-teen — sorry, one hundred ninety-six — sixteen-by-sixteen patches and projects each into a 768-dimension vector. I prepend a learnable class token and add position embeddings, giving a sequence of a hundred and ninety-seven tokens. That sequence goes through twelve Transformer encoder blocks; each block is multi-head self-attention with twelve heads, followed by an MLP that expands 768 to 3072 and back with a GELU, all wrapped in LayerNorm and residual connections. Finally the class token feeds an MLP head that outputs my three classes. I wrote each piece — patch embedding, attention, MLP, encoder — as its own reusable module.</a:t>
+              <a:t>Third, the model itself. This is a Vision Transformer, ViT-Base, and I deliberately built it from scratch rather than importing one, to really understand it. Here's the flow. First, patch embedding: a single Conv2d layer slices the 224-pixel image into one hundred ninety-six sixteen-by-sixteen patches and projects each into a 768-dimension vector. I prepend a learnable class token and add position embeddings, giving a sequence of a hundred and ninety-seven tokens. That sequence goes through twelve Transformer encoder blocks; each block is multi-head self-attention with twelve heads, followed by an MLP that expands 768 to 3072 and back with a GELU, all wrapped in LayerNorm and residual connections. Finally the class token feeds an MLP head that outputs my three classes. I wrote each piece — patch embedding, attention, MLP, encoder — as its own reusable module.</a:t>
             </a:r>
           </a:p>
         </p:txBody>
@@ -6235,7 +6235,7 @@
         <p:spPr>
           <a:xfrm>
             <a:off x="658368" y="1965960"/>
-            <a:ext cx="1933041" cy="841248"/>
+            <a:ext cx="1933041" cy="896112"/>
           </a:xfrm>
           <a:prstGeom prst="roundRect">
             <a:avLst/>
@@ -6265,10 +6265,20 @@
           </a:fontRef>
         </p:style>
         <p:txBody>
-          <a:bodyPr rtlCol="0" anchor="ctr" wrap="square" lIns="54864" rIns="54864"/>
-          <a:lstStyle/>
-          <a:p>
-            <a:pPr algn="ctr"/>
+          <a:bodyPr rtlCol="0" anchor="ctr" wrap="square" lIns="54864" rIns="54864" tIns="27432" bIns="27432"/>
+          <a:lstStyle/>
+          <a:p>
+            <a:pPr algn="ctr">
+              <a:lnSpc>
+                <a:spcPct val="98000"/>
+              </a:lnSpc>
+              <a:spcBef>
+                <a:spcPts val="0"/>
+              </a:spcBef>
+              <a:spcAft>
+                <a:spcPts val="0"/>
+              </a:spcAft>
+            </a:pPr>
             <a:r>
               <a:rPr sz="1150" b="1">
                 <a:solidFill>
@@ -6276,8 +6286,29 @@
                 </a:solidFill>
                 <a:latin typeface="Arial"/>
               </a:rPr>
-              <a:t>OpenLORIS-Object
-(Kaggle)</a:t>
+              <a:t>OpenLORIS-Object</a:t>
+            </a:r>
+          </a:p>
+          <a:p>
+            <a:pPr algn="ctr">
+              <a:lnSpc>
+                <a:spcPct val="98000"/>
+              </a:lnSpc>
+              <a:spcBef>
+                <a:spcPts val="0"/>
+              </a:spcBef>
+              <a:spcAft>
+                <a:spcPts val="0"/>
+              </a:spcAft>
+            </a:pPr>
+            <a:r>
+              <a:rPr sz="900">
+                <a:solidFill>
+                  <a:srgbClr val="64748B"/>
+                </a:solidFill>
+                <a:latin typeface="Arial"/>
+              </a:rPr>
+              <a:t>(Kaggle)</a:t>
             </a:r>
           </a:p>
         </p:txBody>
@@ -6291,7 +6322,7 @@
         <p:spPr>
           <a:xfrm>
             <a:off x="2573121" y="1965960"/>
-            <a:ext cx="329184" cy="841248"/>
+            <a:ext cx="329184" cy="896112"/>
           </a:xfrm>
           <a:prstGeom prst="rect">
             <a:avLst/>
@@ -6330,7 +6361,7 @@
         <p:spPr>
           <a:xfrm>
             <a:off x="2884017" y="1965960"/>
-            <a:ext cx="1933041" cy="841248"/>
+            <a:ext cx="1933041" cy="896112"/>
           </a:xfrm>
           <a:prstGeom prst="roundRect">
             <a:avLst/>
@@ -6360,10 +6391,20 @@
           </a:fontRef>
         </p:style>
         <p:txBody>
-          <a:bodyPr rtlCol="0" anchor="ctr" wrap="square" lIns="54864" rIns="54864"/>
-          <a:lstStyle/>
-          <a:p>
-            <a:pPr algn="ctr"/>
+          <a:bodyPr rtlCol="0" anchor="ctr" wrap="square" lIns="54864" rIns="54864" tIns="27432" bIns="27432"/>
+          <a:lstStyle/>
+          <a:p>
+            <a:pPr algn="ctr">
+              <a:lnSpc>
+                <a:spcPct val="98000"/>
+              </a:lnSpc>
+              <a:spcBef>
+                <a:spcPts val="0"/>
+              </a:spcBef>
+              <a:spcAft>
+                <a:spcPts val="0"/>
+              </a:spcAft>
+            </a:pPr>
             <a:r>
               <a:rPr sz="1150" b="1">
                 <a:solidFill>
@@ -6371,8 +6412,29 @@
                 </a:solidFill>
                 <a:latin typeface="Arial"/>
               </a:rPr>
-              <a:t>Occlusion
-subset</a:t>
+              <a:t>Occlusion</a:t>
+            </a:r>
+          </a:p>
+          <a:p>
+            <a:pPr algn="ctr">
+              <a:lnSpc>
+                <a:spcPct val="98000"/>
+              </a:lnSpc>
+              <a:spcBef>
+                <a:spcPts val="0"/>
+              </a:spcBef>
+              <a:spcAft>
+                <a:spcPts val="0"/>
+              </a:spcAft>
+            </a:pPr>
+            <a:r>
+              <a:rPr sz="900">
+                <a:solidFill>
+                  <a:srgbClr val="64748B"/>
+                </a:solidFill>
+                <a:latin typeface="Arial"/>
+              </a:rPr>
+              <a:t>subset</a:t>
             </a:r>
           </a:p>
         </p:txBody>
@@ -6386,7 +6448,7 @@
         <p:spPr>
           <a:xfrm>
             <a:off x="4798771" y="1965960"/>
-            <a:ext cx="329184" cy="841248"/>
+            <a:ext cx="329184" cy="896112"/>
           </a:xfrm>
           <a:prstGeom prst="rect">
             <a:avLst/>
@@ -6425,7 +6487,7 @@
         <p:spPr>
           <a:xfrm>
             <a:off x="5109667" y="1965960"/>
-            <a:ext cx="1933041" cy="841248"/>
+            <a:ext cx="1933041" cy="896112"/>
           </a:xfrm>
           <a:prstGeom prst="roundRect">
             <a:avLst/>
@@ -6455,10 +6517,20 @@
           </a:fontRef>
         </p:style>
         <p:txBody>
-          <a:bodyPr rtlCol="0" anchor="ctr" wrap="square" lIns="54864" rIns="54864"/>
-          <a:lstStyle/>
-          <a:p>
-            <a:pPr algn="ctr"/>
+          <a:bodyPr rtlCol="0" anchor="ctr" wrap="square" lIns="54864" rIns="54864" tIns="27432" bIns="27432"/>
+          <a:lstStyle/>
+          <a:p>
+            <a:pPr algn="ctr">
+              <a:lnSpc>
+                <a:spcPct val="98000"/>
+              </a:lnSpc>
+              <a:spcBef>
+                <a:spcPts val="0"/>
+              </a:spcBef>
+              <a:spcAft>
+                <a:spcPts val="0"/>
+              </a:spcAft>
+            </a:pPr>
             <a:r>
               <a:rPr sz="1150" b="1">
                 <a:solidFill>
@@ -6466,8 +6538,29 @@
                 </a:solidFill>
                 <a:latin typeface="Arial"/>
               </a:rPr>
-              <a:t>9 tasks →
-3 classes</a:t>
+              <a:t>9 tasks →</a:t>
+            </a:r>
+          </a:p>
+          <a:p>
+            <a:pPr algn="ctr">
+              <a:lnSpc>
+                <a:spcPct val="98000"/>
+              </a:lnSpc>
+              <a:spcBef>
+                <a:spcPts val="0"/>
+              </a:spcBef>
+              <a:spcAft>
+                <a:spcPts val="0"/>
+              </a:spcAft>
+            </a:pPr>
+            <a:r>
+              <a:rPr sz="900">
+                <a:solidFill>
+                  <a:srgbClr val="64748B"/>
+                </a:solidFill>
+                <a:latin typeface="Arial"/>
+              </a:rPr>
+              <a:t>3 classes</a:t>
             </a:r>
           </a:p>
         </p:txBody>
@@ -6481,7 +6574,7 @@
         <p:spPr>
           <a:xfrm>
             <a:off x="7024420" y="1965960"/>
-            <a:ext cx="329184" cy="841248"/>
+            <a:ext cx="329184" cy="896112"/>
           </a:xfrm>
           <a:prstGeom prst="rect">
             <a:avLst/>
@@ -6520,7 +6613,7 @@
         <p:spPr>
           <a:xfrm>
             <a:off x="7335316" y="1965960"/>
-            <a:ext cx="1933041" cy="841248"/>
+            <a:ext cx="1933041" cy="896112"/>
           </a:xfrm>
           <a:prstGeom prst="roundRect">
             <a:avLst/>
@@ -6550,10 +6643,20 @@
           </a:fontRef>
         </p:style>
         <p:txBody>
-          <a:bodyPr rtlCol="0" anchor="ctr" wrap="square" lIns="54864" rIns="54864"/>
-          <a:lstStyle/>
-          <a:p>
-            <a:pPr algn="ctr"/>
+          <a:bodyPr rtlCol="0" anchor="ctr" wrap="square" lIns="54864" rIns="54864" tIns="27432" bIns="27432"/>
+          <a:lstStyle/>
+          <a:p>
+            <a:pPr algn="ctr">
+              <a:lnSpc>
+                <a:spcPct val="98000"/>
+              </a:lnSpc>
+              <a:spcBef>
+                <a:spcPts val="0"/>
+              </a:spcBef>
+              <a:spcAft>
+                <a:spcPts val="0"/>
+              </a:spcAft>
+            </a:pPr>
             <a:r>
               <a:rPr sz="1150" b="1">
                 <a:solidFill>
@@ -6561,8 +6664,29 @@
                 </a:solidFill>
                 <a:latin typeface="Arial"/>
               </a:rPr>
-              <a:t>PickSense Mini
-(300 imgs)</a:t>
+              <a:t>PickSense Mini</a:t>
+            </a:r>
+          </a:p>
+          <a:p>
+            <a:pPr algn="ctr">
+              <a:lnSpc>
+                <a:spcPct val="98000"/>
+              </a:lnSpc>
+              <a:spcBef>
+                <a:spcPts val="0"/>
+              </a:spcBef>
+              <a:spcAft>
+                <a:spcPts val="0"/>
+              </a:spcAft>
+            </a:pPr>
+            <a:r>
+              <a:rPr sz="900">
+                <a:solidFill>
+                  <a:srgbClr val="64748B"/>
+                </a:solidFill>
+                <a:latin typeface="Arial"/>
+              </a:rPr>
+              <a:t>(300 imgs)</a:t>
             </a:r>
           </a:p>
         </p:txBody>
@@ -6576,7 +6700,7 @@
         <p:spPr>
           <a:xfrm>
             <a:off x="9250070" y="1965960"/>
-            <a:ext cx="329184" cy="841248"/>
+            <a:ext cx="329184" cy="896112"/>
           </a:xfrm>
           <a:prstGeom prst="rect">
             <a:avLst/>
@@ -6615,7 +6739,7 @@
         <p:spPr>
           <a:xfrm>
             <a:off x="9560966" y="1965960"/>
-            <a:ext cx="1933041" cy="841248"/>
+            <a:ext cx="1933041" cy="896112"/>
           </a:xfrm>
           <a:prstGeom prst="roundRect">
             <a:avLst/>
@@ -6645,10 +6769,20 @@
           </a:fontRef>
         </p:style>
         <p:txBody>
-          <a:bodyPr rtlCol="0" anchor="ctr" wrap="square" lIns="54864" rIns="54864"/>
-          <a:lstStyle/>
-          <a:p>
-            <a:pPr algn="ctr"/>
+          <a:bodyPr rtlCol="0" anchor="ctr" wrap="square" lIns="54864" rIns="54864" tIns="27432" bIns="27432"/>
+          <a:lstStyle/>
+          <a:p>
+            <a:pPr algn="ctr">
+              <a:lnSpc>
+                <a:spcPct val="98000"/>
+              </a:lnSpc>
+              <a:spcBef>
+                <a:spcPts val="0"/>
+              </a:spcBef>
+              <a:spcAft>
+                <a:spcPts val="0"/>
+              </a:spcAft>
+            </a:pPr>
             <a:r>
               <a:rPr sz="1150" b="1">
                 <a:solidFill>
@@ -6656,8 +6790,29 @@
                 </a:solidFill>
                 <a:latin typeface="Arial"/>
               </a:rPr>
-              <a:t>PyTorch
-DataLoaders</a:t>
+              <a:t>PyTorch</a:t>
+            </a:r>
+          </a:p>
+          <a:p>
+            <a:pPr algn="ctr">
+              <a:lnSpc>
+                <a:spcPct val="98000"/>
+              </a:lnSpc>
+              <a:spcBef>
+                <a:spcPts val="0"/>
+              </a:spcBef>
+              <a:spcAft>
+                <a:spcPts val="0"/>
+              </a:spcAft>
+            </a:pPr>
+            <a:r>
+              <a:rPr sz="900">
+                <a:solidFill>
+                  <a:srgbClr val="64748B"/>
+                </a:solidFill>
+                <a:latin typeface="Arial"/>
+              </a:rPr>
+              <a:t>DataLoaders</a:t>
             </a:r>
           </a:p>
         </p:txBody>
@@ -7346,7 +7501,7 @@
         <p:spPr>
           <a:xfrm>
             <a:off x="658368" y="1965960"/>
-            <a:ext cx="1933041" cy="841248"/>
+            <a:ext cx="1933041" cy="896112"/>
           </a:xfrm>
           <a:prstGeom prst="roundRect">
             <a:avLst/>
@@ -7376,10 +7531,20 @@
           </a:fontRef>
         </p:style>
         <p:txBody>
-          <a:bodyPr rtlCol="0" anchor="ctr" wrap="square" lIns="54864" rIns="54864"/>
-          <a:lstStyle/>
-          <a:p>
-            <a:pPr algn="ctr"/>
+          <a:bodyPr rtlCol="0" anchor="ctr" wrap="square" lIns="54864" rIns="54864" tIns="27432" bIns="27432"/>
+          <a:lstStyle/>
+          <a:p>
+            <a:pPr algn="ctr">
+              <a:lnSpc>
+                <a:spcPct val="98000"/>
+              </a:lnSpc>
+              <a:spcBef>
+                <a:spcPts val="0"/>
+              </a:spcBef>
+              <a:spcAft>
+                <a:spcPts val="0"/>
+              </a:spcAft>
+            </a:pPr>
             <a:r>
               <a:rPr sz="1150" b="1">
                 <a:solidFill>
@@ -7387,8 +7552,29 @@
                 </a:solidFill>
                 <a:latin typeface="Arial"/>
               </a:rPr>
-              <a:t>Patch embedding
-Conv2d 16×16 → 768-d</a:t>
+              <a:t>Patch embedding</a:t>
+            </a:r>
+          </a:p>
+          <a:p>
+            <a:pPr algn="ctr">
+              <a:lnSpc>
+                <a:spcPct val="98000"/>
+              </a:lnSpc>
+              <a:spcBef>
+                <a:spcPts val="0"/>
+              </a:spcBef>
+              <a:spcAft>
+                <a:spcPts val="0"/>
+              </a:spcAft>
+            </a:pPr>
+            <a:r>
+              <a:rPr sz="900">
+                <a:solidFill>
+                  <a:srgbClr val="64748B"/>
+                </a:solidFill>
+                <a:latin typeface="Arial"/>
+              </a:rPr>
+              <a:t>Conv2d 16×16 → 768-d</a:t>
             </a:r>
           </a:p>
         </p:txBody>
@@ -7402,7 +7588,7 @@
         <p:spPr>
           <a:xfrm>
             <a:off x="2573121" y="1965960"/>
-            <a:ext cx="329184" cy="841248"/>
+            <a:ext cx="329184" cy="896112"/>
           </a:xfrm>
           <a:prstGeom prst="rect">
             <a:avLst/>
@@ -7441,7 +7627,7 @@
         <p:spPr>
           <a:xfrm>
             <a:off x="2884017" y="1965960"/>
-            <a:ext cx="1933041" cy="841248"/>
+            <a:ext cx="1933041" cy="896112"/>
           </a:xfrm>
           <a:prstGeom prst="roundRect">
             <a:avLst/>
@@ -7471,10 +7657,20 @@
           </a:fontRef>
         </p:style>
         <p:txBody>
-          <a:bodyPr rtlCol="0" anchor="ctr" wrap="square" lIns="54864" rIns="54864"/>
-          <a:lstStyle/>
-          <a:p>
-            <a:pPr algn="ctr"/>
+          <a:bodyPr rtlCol="0" anchor="ctr" wrap="square" lIns="54864" rIns="54864" tIns="27432" bIns="27432"/>
+          <a:lstStyle/>
+          <a:p>
+            <a:pPr algn="ctr">
+              <a:lnSpc>
+                <a:spcPct val="98000"/>
+              </a:lnSpc>
+              <a:spcBef>
+                <a:spcPts val="0"/>
+              </a:spcBef>
+              <a:spcAft>
+                <a:spcPts val="0"/>
+              </a:spcAft>
+            </a:pPr>
             <a:r>
               <a:rPr sz="1150" b="1">
                 <a:solidFill>
@@ -7496,7 +7692,7 @@
         <p:spPr>
           <a:xfrm>
             <a:off x="4798771" y="1965960"/>
-            <a:ext cx="329184" cy="841248"/>
+            <a:ext cx="329184" cy="896112"/>
           </a:xfrm>
           <a:prstGeom prst="rect">
             <a:avLst/>
@@ -7535,7 +7731,7 @@
         <p:spPr>
           <a:xfrm>
             <a:off x="5109667" y="1965960"/>
-            <a:ext cx="1933041" cy="841248"/>
+            <a:ext cx="1933041" cy="896112"/>
           </a:xfrm>
           <a:prstGeom prst="roundRect">
             <a:avLst/>
@@ -7565,10 +7761,20 @@
           </a:fontRef>
         </p:style>
         <p:txBody>
-          <a:bodyPr rtlCol="0" anchor="ctr" wrap="square" lIns="54864" rIns="54864"/>
-          <a:lstStyle/>
-          <a:p>
-            <a:pPr algn="ctr"/>
+          <a:bodyPr rtlCol="0" anchor="ctr" wrap="square" lIns="54864" rIns="54864" tIns="27432" bIns="27432"/>
+          <a:lstStyle/>
+          <a:p>
+            <a:pPr algn="ctr">
+              <a:lnSpc>
+                <a:spcPct val="98000"/>
+              </a:lnSpc>
+              <a:spcBef>
+                <a:spcPts val="0"/>
+              </a:spcBef>
+              <a:spcAft>
+                <a:spcPts val="0"/>
+              </a:spcAft>
+            </a:pPr>
             <a:r>
               <a:rPr sz="1150" b="1">
                 <a:solidFill>
@@ -7576,8 +7782,29 @@
                 </a:solidFill>
                 <a:latin typeface="Arial"/>
               </a:rPr>
-              <a:t>+ Position
-embedding</a:t>
+              <a:t>+ Position</a:t>
+            </a:r>
+          </a:p>
+          <a:p>
+            <a:pPr algn="ctr">
+              <a:lnSpc>
+                <a:spcPct val="98000"/>
+              </a:lnSpc>
+              <a:spcBef>
+                <a:spcPts val="0"/>
+              </a:spcBef>
+              <a:spcAft>
+                <a:spcPts val="0"/>
+              </a:spcAft>
+            </a:pPr>
+            <a:r>
+              <a:rPr sz="900">
+                <a:solidFill>
+                  <a:srgbClr val="64748B"/>
+                </a:solidFill>
+                <a:latin typeface="Arial"/>
+              </a:rPr>
+              <a:t>embedding</a:t>
             </a:r>
           </a:p>
         </p:txBody>
@@ -7591,7 +7818,7 @@
         <p:spPr>
           <a:xfrm>
             <a:off x="7024420" y="1965960"/>
-            <a:ext cx="329184" cy="841248"/>
+            <a:ext cx="329184" cy="896112"/>
           </a:xfrm>
           <a:prstGeom prst="rect">
             <a:avLst/>
@@ -7630,7 +7857,7 @@
         <p:spPr>
           <a:xfrm>
             <a:off x="7335316" y="1965960"/>
-            <a:ext cx="1933041" cy="841248"/>
+            <a:ext cx="1933041" cy="896112"/>
           </a:xfrm>
           <a:prstGeom prst="roundRect">
             <a:avLst/>
@@ -7660,10 +7887,20 @@
           </a:fontRef>
         </p:style>
         <p:txBody>
-          <a:bodyPr rtlCol="0" anchor="ctr" wrap="square" lIns="54864" rIns="54864"/>
-          <a:lstStyle/>
-          <a:p>
-            <a:pPr algn="ctr"/>
+          <a:bodyPr rtlCol="0" anchor="ctr" wrap="square" lIns="54864" rIns="54864" tIns="27432" bIns="27432"/>
+          <a:lstStyle/>
+          <a:p>
+            <a:pPr algn="ctr">
+              <a:lnSpc>
+                <a:spcPct val="98000"/>
+              </a:lnSpc>
+              <a:spcBef>
+                <a:spcPts val="0"/>
+              </a:spcBef>
+              <a:spcAft>
+                <a:spcPts val="0"/>
+              </a:spcAft>
+            </a:pPr>
             <a:r>
               <a:rPr sz="1150" b="1">
                 <a:solidFill>
@@ -7671,8 +7908,29 @@
                 </a:solidFill>
                 <a:latin typeface="Arial"/>
               </a:rPr>
-              <a:t>Transformer
-Encoder × 12</a:t>
+              <a:t>Transformer</a:t>
+            </a:r>
+          </a:p>
+          <a:p>
+            <a:pPr algn="ctr">
+              <a:lnSpc>
+                <a:spcPct val="98000"/>
+              </a:lnSpc>
+              <a:spcBef>
+                <a:spcPts val="0"/>
+              </a:spcBef>
+              <a:spcAft>
+                <a:spcPts val="0"/>
+              </a:spcAft>
+            </a:pPr>
+            <a:r>
+              <a:rPr sz="900">
+                <a:solidFill>
+                  <a:srgbClr val="64748B"/>
+                </a:solidFill>
+                <a:latin typeface="Arial"/>
+              </a:rPr>
+              <a:t>Encoder × 12</a:t>
             </a:r>
           </a:p>
         </p:txBody>
@@ -7686,7 +7944,7 @@
         <p:spPr>
           <a:xfrm>
             <a:off x="9250070" y="1965960"/>
-            <a:ext cx="329184" cy="841248"/>
+            <a:ext cx="329184" cy="896112"/>
           </a:xfrm>
           <a:prstGeom prst="rect">
             <a:avLst/>
@@ -7725,7 +7983,7 @@
         <p:spPr>
           <a:xfrm>
             <a:off x="9560966" y="1965960"/>
-            <a:ext cx="1933041" cy="841248"/>
+            <a:ext cx="1933041" cy="896112"/>
           </a:xfrm>
           <a:prstGeom prst="roundRect">
             <a:avLst/>
@@ -7755,10 +8013,20 @@
           </a:fontRef>
         </p:style>
         <p:txBody>
-          <a:bodyPr rtlCol="0" anchor="ctr" wrap="square" lIns="54864" rIns="54864"/>
-          <a:lstStyle/>
-          <a:p>
-            <a:pPr algn="ctr"/>
+          <a:bodyPr rtlCol="0" anchor="ctr" wrap="square" lIns="54864" rIns="54864" tIns="27432" bIns="27432"/>
+          <a:lstStyle/>
+          <a:p>
+            <a:pPr algn="ctr">
+              <a:lnSpc>
+                <a:spcPct val="98000"/>
+              </a:lnSpc>
+              <a:spcBef>
+                <a:spcPts val="0"/>
+              </a:spcBef>
+              <a:spcAft>
+                <a:spcPts val="0"/>
+              </a:spcAft>
+            </a:pPr>
             <a:r>
               <a:rPr sz="1150" b="1">
                 <a:solidFill>
@@ -7766,8 +8034,29 @@
                 </a:solidFill>
                 <a:latin typeface="Arial"/>
               </a:rPr>
-              <a:t>MLP head
-→ 3 classes</a:t>
+              <a:t>MLP head</a:t>
+            </a:r>
+          </a:p>
+          <a:p>
+            <a:pPr algn="ctr">
+              <a:lnSpc>
+                <a:spcPct val="98000"/>
+              </a:lnSpc>
+              <a:spcBef>
+                <a:spcPts val="0"/>
+              </a:spcBef>
+              <a:spcAft>
+                <a:spcPts val="0"/>
+              </a:spcAft>
+            </a:pPr>
+            <a:r>
+              <a:rPr sz="900">
+                <a:solidFill>
+                  <a:srgbClr val="64748B"/>
+                </a:solidFill>
+                <a:latin typeface="Arial"/>
+              </a:rPr>
+              <a:t>→ 3 classes</a:t>
             </a:r>
           </a:p>
         </p:txBody>

</xml_diff>